<commit_message>
April 2026 Updates - ATNL_NJ
</commit_message>
<xml_diff>
--- a/IgniteFHIRCombinedTraining.pptx
+++ b/IgniteFHIRCombinedTraining.pptx
@@ -1530,8 +1530,44 @@
           <a:lstStyle/>
           <a:p>
             <a:r>
-              <a:t>Note: AllergyIntolerance/123 is looking up an Allergy by its id (not a patient id). Similarly, AllergyIntolerance?_id=123 is looking up allergy by id, not by the patient id.</a:t>
-            </a:r>
+              <a:rPr dirty="0"/>
+              <a:t>Note: </a:t>
+            </a:r>
+            <a:r>
+              <a:rPr dirty="0" err="1"/>
+              <a:t>AllergyIntolerance</a:t>
+            </a:r>
+            <a:r>
+              <a:rPr dirty="0"/>
+              <a:t>/123 is looking up an Allergy by its id (not a patient id). Similarly, </a:t>
+            </a:r>
+            <a:r>
+              <a:rPr dirty="0" err="1"/>
+              <a:t>AllergyIntolerance</a:t>
+            </a:r>
+            <a:r>
+              <a:rPr dirty="0"/>
+              <a:t>?_id=123 is looking up allergy by id, not by the patient id.</a:t>
+            </a:r>
+            <a:endParaRPr lang="en-US" dirty="0"/>
+          </a:p>
+          <a:p>
+            <a:endParaRPr lang="en-US" dirty="0"/>
+          </a:p>
+          <a:p>
+            <a:r>
+              <a:rPr lang="en-US" dirty="0"/>
+              <a:t>Easy solution to find exact number when a lot of results is search for “</a:t>
+            </a:r>
+            <a:r>
+              <a:rPr lang="en-US" dirty="0" err="1"/>
+              <a:t>fullUrl</a:t>
+            </a:r>
+            <a:r>
+              <a:rPr lang="en-US" dirty="0"/>
+              <a:t>” in results.</a:t>
+            </a:r>
+            <a:endParaRPr dirty="0"/>
           </a:p>
         </p:txBody>
       </p:sp>
@@ -2361,11 +2397,17 @@
           <a:lstStyle/>
           <a:p>
             <a:r>
-              <a:t>StructureDefinition resource (in DSTU 2)</a:t>
-            </a:r>
-          </a:p>
-          <a:p>
-            <a:r>
+              <a:rPr dirty="0" err="1"/>
+              <a:t>StructureDefinition</a:t>
+            </a:r>
+            <a:r>
+              <a:rPr dirty="0"/>
+              <a:t> resource (in DSTU 2)</a:t>
+            </a:r>
+          </a:p>
+          <a:p>
+            <a:r>
+              <a:rPr dirty="0"/>
               <a:t>Detailed description of contracts, per user case or per system</a:t>
             </a:r>
           </a:p>
@@ -5394,7 +5436,7 @@
           </a:ln>
           <a:extLst>
             <a:ext uri="{C572A759-6A51-4108-AA02-DFA0A04FC94B}">
-              <ma14:wrappingTextBoxFlag xmlns:ma14="http://schemas.microsoft.com/office/mac/drawingml/2011/main" xmlns="" val="1"/>
+              <ma14:wrappingTextBoxFlag xmlns="" xmlns:ma14="http://schemas.microsoft.com/office/mac/drawingml/2011/main" val="1"/>
             </a:ext>
           </a:extLst>
         </p:spPr>
@@ -5433,7 +5475,7 @@
           </a:ln>
           <a:extLst>
             <a:ext uri="{C572A759-6A51-4108-AA02-DFA0A04FC94B}">
-              <ma14:wrappingTextBoxFlag xmlns:ma14="http://schemas.microsoft.com/office/mac/drawingml/2011/main" xmlns="" val="1"/>
+              <ma14:wrappingTextBoxFlag xmlns="" xmlns:ma14="http://schemas.microsoft.com/office/mac/drawingml/2011/main" val="1"/>
             </a:ext>
           </a:extLst>
         </p:spPr>
@@ -6515,15 +6557,23 @@
           <a:p>
             <a:r>
               <a:rPr lang="en-US" dirty="0"/>
-              <a:t> 2</a:t>
+              <a:t>April 28</a:t>
             </a:r>
             <a:r>
               <a:rPr lang="en-US" baseline="30000" dirty="0"/>
-              <a:t>nd </a:t>
+              <a:t>th</a:t>
             </a:r>
             <a:r>
               <a:rPr lang="en-US" dirty="0"/>
-              <a:t>of March 2026</a:t>
+              <a:t>,</a:t>
+            </a:r>
+            <a:r>
+              <a:rPr lang="en-US" baseline="30000" dirty="0"/>
+              <a:t> </a:t>
+            </a:r>
+            <a:r>
+              <a:rPr lang="en-US" dirty="0"/>
+              <a:t>2026</a:t>
             </a:r>
           </a:p>
         </p:txBody>
@@ -6766,7 +6816,7 @@
           </a:ln>
           <a:extLst>
             <a:ext uri="{C572A759-6A51-4108-AA02-DFA0A04FC94B}">
-              <ma14:wrappingTextBoxFlag xmlns:ma14="http://schemas.microsoft.com/office/mac/drawingml/2011/main" xmlns="" val="1"/>
+              <ma14:wrappingTextBoxFlag xmlns="" xmlns:ma14="http://schemas.microsoft.com/office/mac/drawingml/2011/main" val="1"/>
             </a:ext>
           </a:extLst>
         </p:spPr>
@@ -7702,7 +7752,7 @@
           </a:ln>
           <a:extLst>
             <a:ext uri="{C572A759-6A51-4108-AA02-DFA0A04FC94B}">
-              <ma14:wrappingTextBoxFlag xmlns:ma14="http://schemas.microsoft.com/office/mac/drawingml/2011/main" xmlns="" val="1"/>
+              <ma14:wrappingTextBoxFlag xmlns="" xmlns:ma14="http://schemas.microsoft.com/office/mac/drawingml/2011/main" val="1"/>
             </a:ext>
           </a:extLst>
         </p:spPr>
@@ -8068,7 +8118,7 @@
           </a:ln>
           <a:extLst>
             <a:ext uri="{C572A759-6A51-4108-AA02-DFA0A04FC94B}">
-              <ma14:wrappingTextBoxFlag xmlns:ma14="http://schemas.microsoft.com/office/mac/drawingml/2011/main" xmlns="" val="1"/>
+              <ma14:wrappingTextBoxFlag xmlns="" xmlns:ma14="http://schemas.microsoft.com/office/mac/drawingml/2011/main" val="1"/>
             </a:ext>
           </a:extLst>
         </p:spPr>
@@ -8215,7 +8265,7 @@
           </a:ln>
           <a:extLst>
             <a:ext uri="{C572A759-6A51-4108-AA02-DFA0A04FC94B}">
-              <ma14:wrappingTextBoxFlag xmlns:ma14="http://schemas.microsoft.com/office/mac/drawingml/2011/main" xmlns="" val="1"/>
+              <ma14:wrappingTextBoxFlag xmlns="" xmlns:ma14="http://schemas.microsoft.com/office/mac/drawingml/2011/main" val="1"/>
             </a:ext>
           </a:extLst>
         </p:spPr>
@@ -8654,7 +8704,7 @@
           </a:ln>
           <a:extLst>
             <a:ext uri="{C572A759-6A51-4108-AA02-DFA0A04FC94B}">
-              <ma14:wrappingTextBoxFlag xmlns:ma14="http://schemas.microsoft.com/office/mac/drawingml/2011/main" xmlns="" val="1"/>
+              <ma14:wrappingTextBoxFlag xmlns="" xmlns:ma14="http://schemas.microsoft.com/office/mac/drawingml/2011/main" val="1"/>
             </a:ext>
           </a:extLst>
         </p:spPr>
@@ -8789,7 +8839,7 @@
           </a:ln>
           <a:extLst>
             <a:ext uri="{C572A759-6A51-4108-AA02-DFA0A04FC94B}">
-              <ma14:wrappingTextBoxFlag xmlns:ma14="http://schemas.microsoft.com/office/mac/drawingml/2011/main" xmlns="" val="1"/>
+              <ma14:wrappingTextBoxFlag xmlns="" xmlns:ma14="http://schemas.microsoft.com/office/mac/drawingml/2011/main" val="1"/>
             </a:ext>
           </a:extLst>
         </p:spPr>
@@ -8990,7 +9040,7 @@
           </a:ln>
           <a:extLst>
             <a:ext uri="{C572A759-6A51-4108-AA02-DFA0A04FC94B}">
-              <ma14:wrappingTextBoxFlag xmlns:ma14="http://schemas.microsoft.com/office/mac/drawingml/2011/main" xmlns="" val="1"/>
+              <ma14:wrappingTextBoxFlag xmlns="" xmlns:ma14="http://schemas.microsoft.com/office/mac/drawingml/2011/main" val="1"/>
             </a:ext>
           </a:extLst>
         </p:spPr>
@@ -9312,7 +9362,7 @@
           </a:ln>
           <a:extLst>
             <a:ext uri="{C572A759-6A51-4108-AA02-DFA0A04FC94B}">
-              <ma14:wrappingTextBoxFlag xmlns:ma14="http://schemas.microsoft.com/office/mac/drawingml/2011/main" xmlns="" val="1"/>
+              <ma14:wrappingTextBoxFlag xmlns="" xmlns:ma14="http://schemas.microsoft.com/office/mac/drawingml/2011/main" val="1"/>
             </a:ext>
           </a:extLst>
         </p:spPr>
@@ -9497,7 +9547,7 @@
           </a:ln>
           <a:extLst>
             <a:ext uri="{C572A759-6A51-4108-AA02-DFA0A04FC94B}">
-              <ma14:wrappingTextBoxFlag xmlns="" xmlns:ma14="http://schemas.microsoft.com/office/mac/drawingml/2011/main" val="1"/>
+              <ma14:wrappingTextBoxFlag xmlns:ma14="http://schemas.microsoft.com/office/mac/drawingml/2011/main" xmlns="" val="1"/>
             </a:ext>
           </a:extLst>
         </p:spPr>
@@ -9671,7 +9721,7 @@
           </a:ln>
           <a:extLst>
             <a:ext uri="{C572A759-6A51-4108-AA02-DFA0A04FC94B}">
-              <ma14:wrappingTextBoxFlag xmlns:ma14="http://schemas.microsoft.com/office/mac/drawingml/2011/main" xmlns="" val="1"/>
+              <ma14:wrappingTextBoxFlag xmlns="" xmlns:ma14="http://schemas.microsoft.com/office/mac/drawingml/2011/main" val="1"/>
             </a:ext>
           </a:extLst>
         </p:spPr>
@@ -9849,7 +9899,7 @@
           </a:ln>
           <a:extLst>
             <a:ext uri="{C572A759-6A51-4108-AA02-DFA0A04FC94B}">
-              <ma14:wrappingTextBoxFlag xmlns:ma14="http://schemas.microsoft.com/office/mac/drawingml/2011/main" xmlns="" val="1"/>
+              <ma14:wrappingTextBoxFlag xmlns="" xmlns:ma14="http://schemas.microsoft.com/office/mac/drawingml/2011/main" val="1"/>
             </a:ext>
           </a:extLst>
         </p:spPr>
@@ -10138,7 +10188,7 @@
           </a:ln>
           <a:extLst>
             <a:ext uri="{C572A759-6A51-4108-AA02-DFA0A04FC94B}">
-              <ma14:wrappingTextBoxFlag xmlns:ma14="http://schemas.microsoft.com/office/mac/drawingml/2011/main" xmlns="" val="1"/>
+              <ma14:wrappingTextBoxFlag xmlns="" xmlns:ma14="http://schemas.microsoft.com/office/mac/drawingml/2011/main" val="1"/>
             </a:ext>
           </a:extLst>
         </p:spPr>
@@ -10283,7 +10333,7 @@
           </a:ln>
           <a:extLst>
             <a:ext uri="{C572A759-6A51-4108-AA02-DFA0A04FC94B}">
-              <ma14:wrappingTextBoxFlag xmlns:ma14="http://schemas.microsoft.com/office/mac/drawingml/2011/main" xmlns="" val="1"/>
+              <ma14:wrappingTextBoxFlag xmlns="" xmlns:ma14="http://schemas.microsoft.com/office/mac/drawingml/2011/main" val="1"/>
             </a:ext>
           </a:extLst>
         </p:spPr>
@@ -10418,7 +10468,7 @@
           </a:ln>
           <a:extLst>
             <a:ext uri="{C572A759-6A51-4108-AA02-DFA0A04FC94B}">
-              <ma14:wrappingTextBoxFlag xmlns="" xmlns:ma14="http://schemas.microsoft.com/office/mac/drawingml/2011/main" val="1"/>
+              <ma14:wrappingTextBoxFlag xmlns:ma14="http://schemas.microsoft.com/office/mac/drawingml/2011/main" xmlns="" val="1"/>
             </a:ext>
           </a:extLst>
         </p:spPr>
@@ -10796,7 +10846,7 @@
           </a:ln>
           <a:extLst>
             <a:ext uri="{C572A759-6A51-4108-AA02-DFA0A04FC94B}">
-              <ma14:wrappingTextBoxFlag xmlns:ma14="http://schemas.microsoft.com/office/mac/drawingml/2011/main" xmlns="" val="1"/>
+              <ma14:wrappingTextBoxFlag xmlns="" xmlns:ma14="http://schemas.microsoft.com/office/mac/drawingml/2011/main" val="1"/>
             </a:ext>
           </a:extLst>
         </p:spPr>
@@ -10902,7 +10952,7 @@
           </a:ln>
           <a:extLst>
             <a:ext uri="{C572A759-6A51-4108-AA02-DFA0A04FC94B}">
-              <ma14:wrappingTextBoxFlag xmlns:ma14="http://schemas.microsoft.com/office/mac/drawingml/2011/main" xmlns="" val="1"/>
+              <ma14:wrappingTextBoxFlag xmlns="" xmlns:ma14="http://schemas.microsoft.com/office/mac/drawingml/2011/main" val="1"/>
             </a:ext>
           </a:extLst>
         </p:spPr>
@@ -11016,7 +11066,7 @@
           </a:ln>
           <a:extLst>
             <a:ext uri="{C572A759-6A51-4108-AA02-DFA0A04FC94B}">
-              <ma14:wrappingTextBoxFlag xmlns:ma14="http://schemas.microsoft.com/office/mac/drawingml/2011/main" xmlns="" val="1"/>
+              <ma14:wrappingTextBoxFlag xmlns="" xmlns:ma14="http://schemas.microsoft.com/office/mac/drawingml/2011/main" val="1"/>
             </a:ext>
           </a:extLst>
         </p:spPr>
@@ -11132,7 +11182,7 @@
           </a:ln>
           <a:extLst>
             <a:ext uri="{C572A759-6A51-4108-AA02-DFA0A04FC94B}">
-              <ma14:wrappingTextBoxFlag xmlns:ma14="http://schemas.microsoft.com/office/mac/drawingml/2011/main" xmlns="" val="1"/>
+              <ma14:wrappingTextBoxFlag xmlns="" xmlns:ma14="http://schemas.microsoft.com/office/mac/drawingml/2011/main" val="1"/>
             </a:ext>
           </a:extLst>
         </p:spPr>
@@ -11182,7 +11232,7 @@
           </a:ln>
           <a:extLst>
             <a:ext uri="{C572A759-6A51-4108-AA02-DFA0A04FC94B}">
-              <ma14:wrappingTextBoxFlag xmlns:ma14="http://schemas.microsoft.com/office/mac/drawingml/2011/main" xmlns="" val="1"/>
+              <ma14:wrappingTextBoxFlag xmlns="" xmlns:ma14="http://schemas.microsoft.com/office/mac/drawingml/2011/main" val="1"/>
             </a:ext>
           </a:extLst>
         </p:spPr>
@@ -11404,7 +11454,7 @@
           </a:ln>
           <a:extLst>
             <a:ext uri="{C572A759-6A51-4108-AA02-DFA0A04FC94B}">
-              <ma14:wrappingTextBoxFlag xmlns:ma14="http://schemas.microsoft.com/office/mac/drawingml/2011/main" xmlns="" val="1"/>
+              <ma14:wrappingTextBoxFlag xmlns="" xmlns:ma14="http://schemas.microsoft.com/office/mac/drawingml/2011/main" val="1"/>
             </a:ext>
           </a:extLst>
         </p:spPr>
@@ -12321,7 +12371,7 @@
           </a:ln>
           <a:extLst>
             <a:ext uri="{C572A759-6A51-4108-AA02-DFA0A04FC94B}">
-              <ma14:wrappingTextBoxFlag xmlns:ma14="http://schemas.microsoft.com/office/mac/drawingml/2011/main" xmlns="" val="1"/>
+              <ma14:wrappingTextBoxFlag xmlns="" xmlns:ma14="http://schemas.microsoft.com/office/mac/drawingml/2011/main" val="1"/>
             </a:ext>
           </a:extLst>
         </p:spPr>
@@ -12587,7 +12637,7 @@
             <a:effectLst/>
             <a:extLst>
               <a:ext uri="{C572A759-6A51-4108-AA02-DFA0A04FC94B}">
-                <ma14:wrappingTextBoxFlag xmlns="" xmlns:ma14="http://schemas.microsoft.com/office/mac/drawingml/2011/main" val="1"/>
+                <ma14:wrappingTextBoxFlag xmlns:ma14="http://schemas.microsoft.com/office/mac/drawingml/2011/main" xmlns="" val="1"/>
               </a:ext>
             </a:extLst>
           </p:spPr>
@@ -12710,7 +12760,7 @@
             <a:effectLst/>
             <a:extLst>
               <a:ext uri="{C572A759-6A51-4108-AA02-DFA0A04FC94B}">
-                <ma14:wrappingTextBoxFlag xmlns="" xmlns:ma14="http://schemas.microsoft.com/office/mac/drawingml/2011/main" val="1"/>
+                <ma14:wrappingTextBoxFlag xmlns:ma14="http://schemas.microsoft.com/office/mac/drawingml/2011/main" xmlns="" val="1"/>
               </a:ext>
             </a:extLst>
           </p:spPr>
@@ -12870,7 +12920,7 @@
             <a:effectLst/>
             <a:extLst>
               <a:ext uri="{C572A759-6A51-4108-AA02-DFA0A04FC94B}">
-                <ma14:wrappingTextBoxFlag xmlns="" xmlns:ma14="http://schemas.microsoft.com/office/mac/drawingml/2011/main" val="1"/>
+                <ma14:wrappingTextBoxFlag xmlns:ma14="http://schemas.microsoft.com/office/mac/drawingml/2011/main" xmlns="" val="1"/>
               </a:ext>
             </a:extLst>
           </p:spPr>
@@ -12914,7 +12964,7 @@
           </a:ln>
           <a:extLst>
             <a:ext uri="{C572A759-6A51-4108-AA02-DFA0A04FC94B}">
-              <ma14:wrappingTextBoxFlag xmlns="" xmlns:ma14="http://schemas.microsoft.com/office/mac/drawingml/2011/main" val="1"/>
+              <ma14:wrappingTextBoxFlag xmlns:ma14="http://schemas.microsoft.com/office/mac/drawingml/2011/main" xmlns="" val="1"/>
             </a:ext>
           </a:extLst>
         </p:spPr>
@@ -12970,7 +13020,7 @@
           </a:ln>
           <a:extLst>
             <a:ext uri="{C572A759-6A51-4108-AA02-DFA0A04FC94B}">
-              <ma14:wrappingTextBoxFlag xmlns="" xmlns:ma14="http://schemas.microsoft.com/office/mac/drawingml/2011/main" val="1"/>
+              <ma14:wrappingTextBoxFlag xmlns:ma14="http://schemas.microsoft.com/office/mac/drawingml/2011/main" xmlns="" val="1"/>
             </a:ext>
           </a:extLst>
         </p:spPr>
@@ -13530,7 +13580,7 @@
           </a:ln>
           <a:extLst>
             <a:ext uri="{C572A759-6A51-4108-AA02-DFA0A04FC94B}">
-              <ma14:wrappingTextBoxFlag xmlns:ma14="http://schemas.microsoft.com/office/mac/drawingml/2011/main" xmlns="" val="1"/>
+              <ma14:wrappingTextBoxFlag xmlns="" xmlns:ma14="http://schemas.microsoft.com/office/mac/drawingml/2011/main" val="1"/>
             </a:ext>
           </a:extLst>
         </p:spPr>
@@ -13734,7 +13784,7 @@
           </a:ln>
           <a:extLst>
             <a:ext uri="{C572A759-6A51-4108-AA02-DFA0A04FC94B}">
-              <ma14:wrappingTextBoxFlag xmlns:ma14="http://schemas.microsoft.com/office/mac/drawingml/2011/main" xmlns="" val="1"/>
+              <ma14:wrappingTextBoxFlag xmlns="" xmlns:ma14="http://schemas.microsoft.com/office/mac/drawingml/2011/main" val="1"/>
             </a:ext>
           </a:extLst>
         </p:spPr>
@@ -13897,7 +13947,7 @@
           </a:ln>
           <a:extLst>
             <a:ext uri="{C572A759-6A51-4108-AA02-DFA0A04FC94B}">
-              <ma14:wrappingTextBoxFlag xmlns:ma14="http://schemas.microsoft.com/office/mac/drawingml/2011/main" xmlns="" val="1"/>
+              <ma14:wrappingTextBoxFlag xmlns="" xmlns:ma14="http://schemas.microsoft.com/office/mac/drawingml/2011/main" val="1"/>
             </a:ext>
           </a:extLst>
         </p:spPr>
@@ -14258,7 +14308,7 @@
           </a:ln>
           <a:extLst>
             <a:ext uri="{C572A759-6A51-4108-AA02-DFA0A04FC94B}">
-              <ma14:wrappingTextBoxFlag xmlns:ma14="http://schemas.microsoft.com/office/mac/drawingml/2011/main" xmlns="" val="1"/>
+              <ma14:wrappingTextBoxFlag xmlns="" xmlns:ma14="http://schemas.microsoft.com/office/mac/drawingml/2011/main" val="1"/>
             </a:ext>
           </a:extLst>
         </p:spPr>
@@ -14374,7 +14424,7 @@
           </a:ln>
           <a:extLst>
             <a:ext uri="{C572A759-6A51-4108-AA02-DFA0A04FC94B}">
-              <ma14:wrappingTextBoxFlag xmlns:ma14="http://schemas.microsoft.com/office/mac/drawingml/2011/main" xmlns="" val="1"/>
+              <ma14:wrappingTextBoxFlag xmlns="" xmlns:ma14="http://schemas.microsoft.com/office/mac/drawingml/2011/main" val="1"/>
             </a:ext>
           </a:extLst>
         </p:spPr>
@@ -14480,7 +14530,7 @@
           </a:ln>
           <a:extLst>
             <a:ext uri="{C572A759-6A51-4108-AA02-DFA0A04FC94B}">
-              <ma14:wrappingTextBoxFlag xmlns:ma14="http://schemas.microsoft.com/office/mac/drawingml/2011/main" xmlns="" val="1"/>
+              <ma14:wrappingTextBoxFlag xmlns="" xmlns:ma14="http://schemas.microsoft.com/office/mac/drawingml/2011/main" val="1"/>
             </a:ext>
           </a:extLst>
         </p:spPr>
@@ -14586,7 +14636,7 @@
           </a:ln>
           <a:extLst>
             <a:ext uri="{C572A759-6A51-4108-AA02-DFA0A04FC94B}">
-              <ma14:wrappingTextBoxFlag xmlns:ma14="http://schemas.microsoft.com/office/mac/drawingml/2011/main" xmlns="" val="1"/>
+              <ma14:wrappingTextBoxFlag xmlns="" xmlns:ma14="http://schemas.microsoft.com/office/mac/drawingml/2011/main" val="1"/>
             </a:ext>
           </a:extLst>
         </p:spPr>
@@ -14636,7 +14686,7 @@
           </a:ln>
           <a:extLst>
             <a:ext uri="{C572A759-6A51-4108-AA02-DFA0A04FC94B}">
-              <ma14:wrappingTextBoxFlag xmlns:ma14="http://schemas.microsoft.com/office/mac/drawingml/2011/main" xmlns="" val="1"/>
+              <ma14:wrappingTextBoxFlag xmlns="" xmlns:ma14="http://schemas.microsoft.com/office/mac/drawingml/2011/main" val="1"/>
             </a:ext>
           </a:extLst>
         </p:spPr>
@@ -14753,7 +14803,7 @@
           </a:ln>
           <a:extLst>
             <a:ext uri="{C572A759-6A51-4108-AA02-DFA0A04FC94B}">
-              <ma14:wrappingTextBoxFlag xmlns:ma14="http://schemas.microsoft.com/office/mac/drawingml/2011/main" xmlns="" val="1"/>
+              <ma14:wrappingTextBoxFlag xmlns="" xmlns:ma14="http://schemas.microsoft.com/office/mac/drawingml/2011/main" val="1"/>
             </a:ext>
           </a:extLst>
         </p:spPr>
@@ -14986,7 +15036,7 @@
           </a:ln>
           <a:extLst>
             <a:ext uri="{C572A759-6A51-4108-AA02-DFA0A04FC94B}">
-              <ma14:wrappingTextBoxFlag xmlns:ma14="http://schemas.microsoft.com/office/mac/drawingml/2011/main" xmlns="" val="1"/>
+              <ma14:wrappingTextBoxFlag xmlns="" xmlns:ma14="http://schemas.microsoft.com/office/mac/drawingml/2011/main" val="1"/>
             </a:ext>
           </a:extLst>
         </p:spPr>
@@ -15036,7 +15086,7 @@
           </a:ln>
           <a:extLst>
             <a:ext uri="{C572A759-6A51-4108-AA02-DFA0A04FC94B}">
-              <ma14:wrappingTextBoxFlag xmlns:ma14="http://schemas.microsoft.com/office/mac/drawingml/2011/main" xmlns="" val="1"/>
+              <ma14:wrappingTextBoxFlag xmlns="" xmlns:ma14="http://schemas.microsoft.com/office/mac/drawingml/2011/main" val="1"/>
             </a:ext>
           </a:extLst>
         </p:spPr>
@@ -15931,7 +15981,7 @@
           </a:ln>
           <a:extLst>
             <a:ext uri="{C572A759-6A51-4108-AA02-DFA0A04FC94B}">
-              <ma14:wrappingTextBoxFlag xmlns:ma14="http://schemas.microsoft.com/office/mac/drawingml/2011/main" xmlns="" val="1"/>
+              <ma14:wrappingTextBoxFlag xmlns="" xmlns:ma14="http://schemas.microsoft.com/office/mac/drawingml/2011/main" val="1"/>
             </a:ext>
           </a:extLst>
         </p:spPr>
@@ -16115,7 +16165,7 @@
           </a:ln>
           <a:extLst>
             <a:ext uri="{C572A759-6A51-4108-AA02-DFA0A04FC94B}">
-              <ma14:wrappingTextBoxFlag xmlns:ma14="http://schemas.microsoft.com/office/mac/drawingml/2011/main" xmlns="" val="1"/>
+              <ma14:wrappingTextBoxFlag xmlns="" xmlns:ma14="http://schemas.microsoft.com/office/mac/drawingml/2011/main" val="1"/>
             </a:ext>
           </a:extLst>
         </p:spPr>
@@ -16262,7 +16312,7 @@
           </a:ln>
           <a:extLst>
             <a:ext uri="{C572A759-6A51-4108-AA02-DFA0A04FC94B}">
-              <ma14:wrappingTextBoxFlag xmlns:ma14="http://schemas.microsoft.com/office/mac/drawingml/2011/main" xmlns="" val="1"/>
+              <ma14:wrappingTextBoxFlag xmlns="" xmlns:ma14="http://schemas.microsoft.com/office/mac/drawingml/2011/main" val="1"/>
             </a:ext>
           </a:extLst>
         </p:spPr>
@@ -16419,7 +16469,7 @@
           </a:ln>
           <a:extLst>
             <a:ext uri="{C572A759-6A51-4108-AA02-DFA0A04FC94B}">
-              <ma14:wrappingTextBoxFlag xmlns="" xmlns:ma14="http://schemas.microsoft.com/office/mac/drawingml/2011/main" val="1"/>
+              <ma14:wrappingTextBoxFlag xmlns:ma14="http://schemas.microsoft.com/office/mac/drawingml/2011/main" xmlns="" val="1"/>
             </a:ext>
           </a:extLst>
         </p:spPr>
@@ -16571,7 +16621,7 @@
           </a:ln>
           <a:extLst>
             <a:ext uri="{C572A759-6A51-4108-AA02-DFA0A04FC94B}">
-              <ma14:wrappingTextBoxFlag xmlns:ma14="http://schemas.microsoft.com/office/mac/drawingml/2011/main" xmlns="" val="1"/>
+              <ma14:wrappingTextBoxFlag xmlns="" xmlns:ma14="http://schemas.microsoft.com/office/mac/drawingml/2011/main" val="1"/>
             </a:ext>
           </a:extLst>
         </p:spPr>
@@ -17147,7 +17197,7 @@
           </a:ln>
           <a:extLst>
             <a:ext uri="{C572A759-6A51-4108-AA02-DFA0A04FC94B}">
-              <ma14:wrappingTextBoxFlag xmlns="" xmlns:ma14="http://schemas.microsoft.com/office/mac/drawingml/2011/main" val="1"/>
+              <ma14:wrappingTextBoxFlag xmlns:ma14="http://schemas.microsoft.com/office/mac/drawingml/2011/main" xmlns="" val="1"/>
             </a:ext>
           </a:extLst>
         </p:spPr>
@@ -17749,7 +17799,7 @@
           </a:ln>
           <a:extLst>
             <a:ext uri="{C572A759-6A51-4108-AA02-DFA0A04FC94B}">
-              <ma14:wrappingTextBoxFlag xmlns:ma14="http://schemas.microsoft.com/office/mac/drawingml/2011/main" xmlns="" val="1"/>
+              <ma14:wrappingTextBoxFlag xmlns="" xmlns:ma14="http://schemas.microsoft.com/office/mac/drawingml/2011/main" val="1"/>
             </a:ext>
           </a:extLst>
         </p:spPr>
@@ -17883,7 +17933,7 @@
           </a:ln>
           <a:extLst>
             <a:ext uri="{C572A759-6A51-4108-AA02-DFA0A04FC94B}">
-              <ma14:wrappingTextBoxFlag xmlns:ma14="http://schemas.microsoft.com/office/mac/drawingml/2011/main" xmlns="" val="1"/>
+              <ma14:wrappingTextBoxFlag xmlns="" xmlns:ma14="http://schemas.microsoft.com/office/mac/drawingml/2011/main" val="1"/>
             </a:ext>
           </a:extLst>
         </p:spPr>
@@ -18417,7 +18467,7 @@
           </a:ln>
           <a:extLst>
             <a:ext uri="{C572A759-6A51-4108-AA02-DFA0A04FC94B}">
-              <ma14:wrappingTextBoxFlag xmlns:ma14="http://schemas.microsoft.com/office/mac/drawingml/2011/main" xmlns="" val="1"/>
+              <ma14:wrappingTextBoxFlag xmlns="" xmlns:ma14="http://schemas.microsoft.com/office/mac/drawingml/2011/main" val="1"/>
             </a:ext>
           </a:extLst>
         </p:spPr>
@@ -18534,7 +18584,7 @@
           </a:ln>
           <a:extLst>
             <a:ext uri="{C572A759-6A51-4108-AA02-DFA0A04FC94B}">
-              <ma14:wrappingTextBoxFlag xmlns:ma14="http://schemas.microsoft.com/office/mac/drawingml/2011/main" xmlns="" val="1"/>
+              <ma14:wrappingTextBoxFlag xmlns="" xmlns:ma14="http://schemas.microsoft.com/office/mac/drawingml/2011/main" val="1"/>
             </a:ext>
           </a:extLst>
         </p:spPr>
@@ -18994,7 +19044,7 @@
           </a:ln>
           <a:extLst>
             <a:ext uri="{C572A759-6A51-4108-AA02-DFA0A04FC94B}">
-              <ma14:wrappingTextBoxFlag xmlns:ma14="http://schemas.microsoft.com/office/mac/drawingml/2011/main" xmlns="" val="1"/>
+              <ma14:wrappingTextBoxFlag xmlns="" xmlns:ma14="http://schemas.microsoft.com/office/mac/drawingml/2011/main" val="1"/>
             </a:ext>
           </a:extLst>
         </p:spPr>
@@ -19137,7 +19187,7 @@
           </a:ln>
           <a:extLst>
             <a:ext uri="{C572A759-6A51-4108-AA02-DFA0A04FC94B}">
-              <ma14:wrappingTextBoxFlag xmlns:ma14="http://schemas.microsoft.com/office/mac/drawingml/2011/main" xmlns="" val="1"/>
+              <ma14:wrappingTextBoxFlag xmlns="" xmlns:ma14="http://schemas.microsoft.com/office/mac/drawingml/2011/main" val="1"/>
             </a:ext>
           </a:extLst>
         </p:spPr>
@@ -19722,7 +19772,7 @@
           </a:ln>
           <a:extLst>
             <a:ext uri="{C572A759-6A51-4108-AA02-DFA0A04FC94B}">
-              <ma14:wrappingTextBoxFlag xmlns:ma14="http://schemas.microsoft.com/office/mac/drawingml/2011/main" xmlns="" val="1"/>
+              <ma14:wrappingTextBoxFlag xmlns="" xmlns:ma14="http://schemas.microsoft.com/office/mac/drawingml/2011/main" val="1"/>
             </a:ext>
           </a:extLst>
         </p:spPr>
@@ -19774,7 +19824,7 @@
           </a:ln>
           <a:extLst>
             <a:ext uri="{C572A759-6A51-4108-AA02-DFA0A04FC94B}">
-              <ma14:wrappingTextBoxFlag xmlns:ma14="http://schemas.microsoft.com/office/mac/drawingml/2011/main" xmlns="" val="1"/>
+              <ma14:wrappingTextBoxFlag xmlns="" xmlns:ma14="http://schemas.microsoft.com/office/mac/drawingml/2011/main" val="1"/>
             </a:ext>
           </a:extLst>
         </p:spPr>
@@ -19877,7 +19927,7 @@
           </a:ln>
           <a:extLst>
             <a:ext uri="{C572A759-6A51-4108-AA02-DFA0A04FC94B}">
-              <ma14:wrappingTextBoxFlag xmlns:ma14="http://schemas.microsoft.com/office/mac/drawingml/2011/main" xmlns="" val="1"/>
+              <ma14:wrappingTextBoxFlag xmlns="" xmlns:ma14="http://schemas.microsoft.com/office/mac/drawingml/2011/main" val="1"/>
             </a:ext>
           </a:extLst>
         </p:spPr>
@@ -19991,7 +20041,7 @@
           </a:ln>
           <a:extLst>
             <a:ext uri="{C572A759-6A51-4108-AA02-DFA0A04FC94B}">
-              <ma14:wrappingTextBoxFlag xmlns:ma14="http://schemas.microsoft.com/office/mac/drawingml/2011/main" xmlns="" val="1"/>
+              <ma14:wrappingTextBoxFlag xmlns="" xmlns:ma14="http://schemas.microsoft.com/office/mac/drawingml/2011/main" val="1"/>
             </a:ext>
           </a:extLst>
         </p:spPr>
@@ -20178,7 +20228,7 @@
           </a:ln>
           <a:extLst>
             <a:ext uri="{C572A759-6A51-4108-AA02-DFA0A04FC94B}">
-              <ma14:wrappingTextBoxFlag xmlns:ma14="http://schemas.microsoft.com/office/mac/drawingml/2011/main" xmlns="" val="1"/>
+              <ma14:wrappingTextBoxFlag xmlns="" xmlns:ma14="http://schemas.microsoft.com/office/mac/drawingml/2011/main" val="1"/>
             </a:ext>
           </a:extLst>
         </p:spPr>
@@ -20848,7 +20898,7 @@
           </a:ln>
           <a:extLst>
             <a:ext uri="{C572A759-6A51-4108-AA02-DFA0A04FC94B}">
-              <ma14:wrappingTextBoxFlag xmlns="" xmlns:ma14="http://schemas.microsoft.com/office/mac/drawingml/2011/main" val="1"/>
+              <ma14:wrappingTextBoxFlag xmlns:ma14="http://schemas.microsoft.com/office/mac/drawingml/2011/main" xmlns="" val="1"/>
             </a:ext>
           </a:extLst>
         </p:spPr>
@@ -21215,7 +21265,7 @@
           </a:ln>
           <a:extLst>
             <a:ext uri="{C572A759-6A51-4108-AA02-DFA0A04FC94B}">
-              <ma14:wrappingTextBoxFlag xmlns="" xmlns:ma14="http://schemas.microsoft.com/office/mac/drawingml/2011/main" val="1"/>
+              <ma14:wrappingTextBoxFlag xmlns:ma14="http://schemas.microsoft.com/office/mac/drawingml/2011/main" xmlns="" val="1"/>
             </a:ext>
           </a:extLst>
         </p:spPr>
@@ -21382,7 +21432,7 @@
           </a:ln>
           <a:extLst>
             <a:ext uri="{C572A759-6A51-4108-AA02-DFA0A04FC94B}">
-              <ma14:wrappingTextBoxFlag xmlns="" xmlns:ma14="http://schemas.microsoft.com/office/mac/drawingml/2011/main" val="1"/>
+              <ma14:wrappingTextBoxFlag xmlns:ma14="http://schemas.microsoft.com/office/mac/drawingml/2011/main" xmlns="" val="1"/>
             </a:ext>
           </a:extLst>
         </p:spPr>
@@ -21449,7 +21499,7 @@
           </a:ln>
           <a:extLst>
             <a:ext uri="{C572A759-6A51-4108-AA02-DFA0A04FC94B}">
-              <ma14:wrappingTextBoxFlag xmlns:ma14="http://schemas.microsoft.com/office/mac/drawingml/2011/main" xmlns="" val="1"/>
+              <ma14:wrappingTextBoxFlag xmlns="" xmlns:ma14="http://schemas.microsoft.com/office/mac/drawingml/2011/main" val="1"/>
             </a:ext>
           </a:extLst>
         </p:spPr>
@@ -21640,7 +21690,7 @@
           </a:ln>
           <a:extLst>
             <a:ext uri="{C572A759-6A51-4108-AA02-DFA0A04FC94B}">
-              <ma14:wrappingTextBoxFlag xmlns:ma14="http://schemas.microsoft.com/office/mac/drawingml/2011/main" xmlns="" val="1"/>
+              <ma14:wrappingTextBoxFlag xmlns="" xmlns:ma14="http://schemas.microsoft.com/office/mac/drawingml/2011/main" val="1"/>
             </a:ext>
           </a:extLst>
         </p:spPr>
@@ -21781,7 +21831,7 @@
           </a:ln>
           <a:extLst>
             <a:ext uri="{C572A759-6A51-4108-AA02-DFA0A04FC94B}">
-              <ma14:wrappingTextBoxFlag xmlns:ma14="http://schemas.microsoft.com/office/mac/drawingml/2011/main" xmlns="" val="1"/>
+              <ma14:wrappingTextBoxFlag xmlns="" xmlns:ma14="http://schemas.microsoft.com/office/mac/drawingml/2011/main" val="1"/>
             </a:ext>
           </a:extLst>
         </p:spPr>
@@ -22515,7 +22565,7 @@
           </a:ln>
           <a:extLst>
             <a:ext uri="{C572A759-6A51-4108-AA02-DFA0A04FC94B}">
-              <ma14:wrappingTextBoxFlag xmlns:ma14="http://schemas.microsoft.com/office/mac/drawingml/2011/main" xmlns="" val="1"/>
+              <ma14:wrappingTextBoxFlag xmlns="" xmlns:ma14="http://schemas.microsoft.com/office/mac/drawingml/2011/main" val="1"/>
             </a:ext>
           </a:extLst>
         </p:spPr>
@@ -22888,7 +22938,7 @@
           <a:p>
             <a:r>
               <a:rPr lang="en-US" dirty="0"/>
-              <a:t>It’s normal (120/80)</a:t>
+              <a:t>Hard to tell (Unknown/75)</a:t>
             </a:r>
           </a:p>
           <a:p>

</xml_diff>

<commit_message>
August 2026 Updates - CCH NHS UK
</commit_message>
<xml_diff>
--- a/IgniteFHIRCombinedTraining.pptx
+++ b/IgniteFHIRCombinedTraining.pptx
@@ -5436,7 +5436,7 @@
           </a:ln>
           <a:extLst>
             <a:ext uri="{C572A759-6A51-4108-AA02-DFA0A04FC94B}">
-              <ma14:wrappingTextBoxFlag xmlns="" xmlns:ma14="http://schemas.microsoft.com/office/mac/drawingml/2011/main" val="1"/>
+              <ma14:wrappingTextBoxFlag xmlns:ma14="http://schemas.microsoft.com/office/mac/drawingml/2011/main" xmlns="" val="1"/>
             </a:ext>
           </a:extLst>
         </p:spPr>
@@ -5475,7 +5475,7 @@
           </a:ln>
           <a:extLst>
             <a:ext uri="{C572A759-6A51-4108-AA02-DFA0A04FC94B}">
-              <ma14:wrappingTextBoxFlag xmlns="" xmlns:ma14="http://schemas.microsoft.com/office/mac/drawingml/2011/main" val="1"/>
+              <ma14:wrappingTextBoxFlag xmlns:ma14="http://schemas.microsoft.com/office/mac/drawingml/2011/main" xmlns="" val="1"/>
             </a:ext>
           </a:extLst>
         </p:spPr>
@@ -6557,15 +6557,15 @@
           <a:p>
             <a:r>
               <a:rPr lang="en-US" dirty="0"/>
-              <a:t>April 28</a:t>
+              <a:t>18</a:t>
             </a:r>
             <a:r>
               <a:rPr lang="en-US" baseline="30000" dirty="0"/>
-              <a:t>th</a:t>
+              <a:t>th </a:t>
             </a:r>
             <a:r>
               <a:rPr lang="en-US" dirty="0"/>
-              <a:t>,</a:t>
+              <a:t>of August</a:t>
             </a:r>
             <a:r>
               <a:rPr lang="en-US" baseline="30000" dirty="0"/>
@@ -6816,7 +6816,7 @@
           </a:ln>
           <a:extLst>
             <a:ext uri="{C572A759-6A51-4108-AA02-DFA0A04FC94B}">
-              <ma14:wrappingTextBoxFlag xmlns="" xmlns:ma14="http://schemas.microsoft.com/office/mac/drawingml/2011/main" val="1"/>
+              <ma14:wrappingTextBoxFlag xmlns:ma14="http://schemas.microsoft.com/office/mac/drawingml/2011/main" xmlns="" val="1"/>
             </a:ext>
           </a:extLst>
         </p:spPr>
@@ -7752,7 +7752,7 @@
           </a:ln>
           <a:extLst>
             <a:ext uri="{C572A759-6A51-4108-AA02-DFA0A04FC94B}">
-              <ma14:wrappingTextBoxFlag xmlns="" xmlns:ma14="http://schemas.microsoft.com/office/mac/drawingml/2011/main" val="1"/>
+              <ma14:wrappingTextBoxFlag xmlns:ma14="http://schemas.microsoft.com/office/mac/drawingml/2011/main" xmlns="" val="1"/>
             </a:ext>
           </a:extLst>
         </p:spPr>
@@ -8118,7 +8118,7 @@
           </a:ln>
           <a:extLst>
             <a:ext uri="{C572A759-6A51-4108-AA02-DFA0A04FC94B}">
-              <ma14:wrappingTextBoxFlag xmlns="" xmlns:ma14="http://schemas.microsoft.com/office/mac/drawingml/2011/main" val="1"/>
+              <ma14:wrappingTextBoxFlag xmlns:ma14="http://schemas.microsoft.com/office/mac/drawingml/2011/main" xmlns="" val="1"/>
             </a:ext>
           </a:extLst>
         </p:spPr>
@@ -8265,7 +8265,7 @@
           </a:ln>
           <a:extLst>
             <a:ext uri="{C572A759-6A51-4108-AA02-DFA0A04FC94B}">
-              <ma14:wrappingTextBoxFlag xmlns="" xmlns:ma14="http://schemas.microsoft.com/office/mac/drawingml/2011/main" val="1"/>
+              <ma14:wrappingTextBoxFlag xmlns:ma14="http://schemas.microsoft.com/office/mac/drawingml/2011/main" xmlns="" val="1"/>
             </a:ext>
           </a:extLst>
         </p:spPr>
@@ -8704,7 +8704,7 @@
           </a:ln>
           <a:extLst>
             <a:ext uri="{C572A759-6A51-4108-AA02-DFA0A04FC94B}">
-              <ma14:wrappingTextBoxFlag xmlns="" xmlns:ma14="http://schemas.microsoft.com/office/mac/drawingml/2011/main" val="1"/>
+              <ma14:wrappingTextBoxFlag xmlns:ma14="http://schemas.microsoft.com/office/mac/drawingml/2011/main" xmlns="" val="1"/>
             </a:ext>
           </a:extLst>
         </p:spPr>
@@ -8839,7 +8839,7 @@
           </a:ln>
           <a:extLst>
             <a:ext uri="{C572A759-6A51-4108-AA02-DFA0A04FC94B}">
-              <ma14:wrappingTextBoxFlag xmlns="" xmlns:ma14="http://schemas.microsoft.com/office/mac/drawingml/2011/main" val="1"/>
+              <ma14:wrappingTextBoxFlag xmlns:ma14="http://schemas.microsoft.com/office/mac/drawingml/2011/main" xmlns="" val="1"/>
             </a:ext>
           </a:extLst>
         </p:spPr>
@@ -9040,7 +9040,7 @@
           </a:ln>
           <a:extLst>
             <a:ext uri="{C572A759-6A51-4108-AA02-DFA0A04FC94B}">
-              <ma14:wrappingTextBoxFlag xmlns="" xmlns:ma14="http://schemas.microsoft.com/office/mac/drawingml/2011/main" val="1"/>
+              <ma14:wrappingTextBoxFlag xmlns:ma14="http://schemas.microsoft.com/office/mac/drawingml/2011/main" xmlns="" val="1"/>
             </a:ext>
           </a:extLst>
         </p:spPr>
@@ -9362,7 +9362,7 @@
           </a:ln>
           <a:extLst>
             <a:ext uri="{C572A759-6A51-4108-AA02-DFA0A04FC94B}">
-              <ma14:wrappingTextBoxFlag xmlns="" xmlns:ma14="http://schemas.microsoft.com/office/mac/drawingml/2011/main" val="1"/>
+              <ma14:wrappingTextBoxFlag xmlns:ma14="http://schemas.microsoft.com/office/mac/drawingml/2011/main" xmlns="" val="1"/>
             </a:ext>
           </a:extLst>
         </p:spPr>
@@ -9547,7 +9547,7 @@
           </a:ln>
           <a:extLst>
             <a:ext uri="{C572A759-6A51-4108-AA02-DFA0A04FC94B}">
-              <ma14:wrappingTextBoxFlag xmlns:ma14="http://schemas.microsoft.com/office/mac/drawingml/2011/main" xmlns="" val="1"/>
+              <ma14:wrappingTextBoxFlag xmlns="" xmlns:ma14="http://schemas.microsoft.com/office/mac/drawingml/2011/main" val="1"/>
             </a:ext>
           </a:extLst>
         </p:spPr>
@@ -9721,7 +9721,7 @@
           </a:ln>
           <a:extLst>
             <a:ext uri="{C572A759-6A51-4108-AA02-DFA0A04FC94B}">
-              <ma14:wrappingTextBoxFlag xmlns="" xmlns:ma14="http://schemas.microsoft.com/office/mac/drawingml/2011/main" val="1"/>
+              <ma14:wrappingTextBoxFlag xmlns:ma14="http://schemas.microsoft.com/office/mac/drawingml/2011/main" xmlns="" val="1"/>
             </a:ext>
           </a:extLst>
         </p:spPr>
@@ -9899,7 +9899,7 @@
           </a:ln>
           <a:extLst>
             <a:ext uri="{C572A759-6A51-4108-AA02-DFA0A04FC94B}">
-              <ma14:wrappingTextBoxFlag xmlns="" xmlns:ma14="http://schemas.microsoft.com/office/mac/drawingml/2011/main" val="1"/>
+              <ma14:wrappingTextBoxFlag xmlns:ma14="http://schemas.microsoft.com/office/mac/drawingml/2011/main" xmlns="" val="1"/>
             </a:ext>
           </a:extLst>
         </p:spPr>
@@ -10188,7 +10188,7 @@
           </a:ln>
           <a:extLst>
             <a:ext uri="{C572A759-6A51-4108-AA02-DFA0A04FC94B}">
-              <ma14:wrappingTextBoxFlag xmlns="" xmlns:ma14="http://schemas.microsoft.com/office/mac/drawingml/2011/main" val="1"/>
+              <ma14:wrappingTextBoxFlag xmlns:ma14="http://schemas.microsoft.com/office/mac/drawingml/2011/main" xmlns="" val="1"/>
             </a:ext>
           </a:extLst>
         </p:spPr>
@@ -10333,7 +10333,7 @@
           </a:ln>
           <a:extLst>
             <a:ext uri="{C572A759-6A51-4108-AA02-DFA0A04FC94B}">
-              <ma14:wrappingTextBoxFlag xmlns="" xmlns:ma14="http://schemas.microsoft.com/office/mac/drawingml/2011/main" val="1"/>
+              <ma14:wrappingTextBoxFlag xmlns:ma14="http://schemas.microsoft.com/office/mac/drawingml/2011/main" xmlns="" val="1"/>
             </a:ext>
           </a:extLst>
         </p:spPr>
@@ -10468,7 +10468,7 @@
           </a:ln>
           <a:extLst>
             <a:ext uri="{C572A759-6A51-4108-AA02-DFA0A04FC94B}">
-              <ma14:wrappingTextBoxFlag xmlns:ma14="http://schemas.microsoft.com/office/mac/drawingml/2011/main" xmlns="" val="1"/>
+              <ma14:wrappingTextBoxFlag xmlns="" xmlns:ma14="http://schemas.microsoft.com/office/mac/drawingml/2011/main" val="1"/>
             </a:ext>
           </a:extLst>
         </p:spPr>
@@ -10846,7 +10846,7 @@
           </a:ln>
           <a:extLst>
             <a:ext uri="{C572A759-6A51-4108-AA02-DFA0A04FC94B}">
-              <ma14:wrappingTextBoxFlag xmlns="" xmlns:ma14="http://schemas.microsoft.com/office/mac/drawingml/2011/main" val="1"/>
+              <ma14:wrappingTextBoxFlag xmlns:ma14="http://schemas.microsoft.com/office/mac/drawingml/2011/main" xmlns="" val="1"/>
             </a:ext>
           </a:extLst>
         </p:spPr>
@@ -10952,7 +10952,7 @@
           </a:ln>
           <a:extLst>
             <a:ext uri="{C572A759-6A51-4108-AA02-DFA0A04FC94B}">
-              <ma14:wrappingTextBoxFlag xmlns="" xmlns:ma14="http://schemas.microsoft.com/office/mac/drawingml/2011/main" val="1"/>
+              <ma14:wrappingTextBoxFlag xmlns:ma14="http://schemas.microsoft.com/office/mac/drawingml/2011/main" xmlns="" val="1"/>
             </a:ext>
           </a:extLst>
         </p:spPr>
@@ -11066,7 +11066,7 @@
           </a:ln>
           <a:extLst>
             <a:ext uri="{C572A759-6A51-4108-AA02-DFA0A04FC94B}">
-              <ma14:wrappingTextBoxFlag xmlns="" xmlns:ma14="http://schemas.microsoft.com/office/mac/drawingml/2011/main" val="1"/>
+              <ma14:wrappingTextBoxFlag xmlns:ma14="http://schemas.microsoft.com/office/mac/drawingml/2011/main" xmlns="" val="1"/>
             </a:ext>
           </a:extLst>
         </p:spPr>
@@ -11182,7 +11182,7 @@
           </a:ln>
           <a:extLst>
             <a:ext uri="{C572A759-6A51-4108-AA02-DFA0A04FC94B}">
-              <ma14:wrappingTextBoxFlag xmlns="" xmlns:ma14="http://schemas.microsoft.com/office/mac/drawingml/2011/main" val="1"/>
+              <ma14:wrappingTextBoxFlag xmlns:ma14="http://schemas.microsoft.com/office/mac/drawingml/2011/main" xmlns="" val="1"/>
             </a:ext>
           </a:extLst>
         </p:spPr>
@@ -11232,7 +11232,7 @@
           </a:ln>
           <a:extLst>
             <a:ext uri="{C572A759-6A51-4108-AA02-DFA0A04FC94B}">
-              <ma14:wrappingTextBoxFlag xmlns="" xmlns:ma14="http://schemas.microsoft.com/office/mac/drawingml/2011/main" val="1"/>
+              <ma14:wrappingTextBoxFlag xmlns:ma14="http://schemas.microsoft.com/office/mac/drawingml/2011/main" xmlns="" val="1"/>
             </a:ext>
           </a:extLst>
         </p:spPr>
@@ -11454,7 +11454,7 @@
           </a:ln>
           <a:extLst>
             <a:ext uri="{C572A759-6A51-4108-AA02-DFA0A04FC94B}">
-              <ma14:wrappingTextBoxFlag xmlns="" xmlns:ma14="http://schemas.microsoft.com/office/mac/drawingml/2011/main" val="1"/>
+              <ma14:wrappingTextBoxFlag xmlns:ma14="http://schemas.microsoft.com/office/mac/drawingml/2011/main" xmlns="" val="1"/>
             </a:ext>
           </a:extLst>
         </p:spPr>
@@ -12371,7 +12371,7 @@
           </a:ln>
           <a:extLst>
             <a:ext uri="{C572A759-6A51-4108-AA02-DFA0A04FC94B}">
-              <ma14:wrappingTextBoxFlag xmlns="" xmlns:ma14="http://schemas.microsoft.com/office/mac/drawingml/2011/main" val="1"/>
+              <ma14:wrappingTextBoxFlag xmlns:ma14="http://schemas.microsoft.com/office/mac/drawingml/2011/main" xmlns="" val="1"/>
             </a:ext>
           </a:extLst>
         </p:spPr>
@@ -12637,7 +12637,7 @@
             <a:effectLst/>
             <a:extLst>
               <a:ext uri="{C572A759-6A51-4108-AA02-DFA0A04FC94B}">
-                <ma14:wrappingTextBoxFlag xmlns:ma14="http://schemas.microsoft.com/office/mac/drawingml/2011/main" xmlns="" val="1"/>
+                <ma14:wrappingTextBoxFlag xmlns="" xmlns:ma14="http://schemas.microsoft.com/office/mac/drawingml/2011/main" val="1"/>
               </a:ext>
             </a:extLst>
           </p:spPr>
@@ -12760,7 +12760,7 @@
             <a:effectLst/>
             <a:extLst>
               <a:ext uri="{C572A759-6A51-4108-AA02-DFA0A04FC94B}">
-                <ma14:wrappingTextBoxFlag xmlns:ma14="http://schemas.microsoft.com/office/mac/drawingml/2011/main" xmlns="" val="1"/>
+                <ma14:wrappingTextBoxFlag xmlns="" xmlns:ma14="http://schemas.microsoft.com/office/mac/drawingml/2011/main" val="1"/>
               </a:ext>
             </a:extLst>
           </p:spPr>
@@ -12920,7 +12920,7 @@
             <a:effectLst/>
             <a:extLst>
               <a:ext uri="{C572A759-6A51-4108-AA02-DFA0A04FC94B}">
-                <ma14:wrappingTextBoxFlag xmlns:ma14="http://schemas.microsoft.com/office/mac/drawingml/2011/main" xmlns="" val="1"/>
+                <ma14:wrappingTextBoxFlag xmlns="" xmlns:ma14="http://schemas.microsoft.com/office/mac/drawingml/2011/main" val="1"/>
               </a:ext>
             </a:extLst>
           </p:spPr>
@@ -12964,7 +12964,7 @@
           </a:ln>
           <a:extLst>
             <a:ext uri="{C572A759-6A51-4108-AA02-DFA0A04FC94B}">
-              <ma14:wrappingTextBoxFlag xmlns:ma14="http://schemas.microsoft.com/office/mac/drawingml/2011/main" xmlns="" val="1"/>
+              <ma14:wrappingTextBoxFlag xmlns="" xmlns:ma14="http://schemas.microsoft.com/office/mac/drawingml/2011/main" val="1"/>
             </a:ext>
           </a:extLst>
         </p:spPr>
@@ -13020,7 +13020,7 @@
           </a:ln>
           <a:extLst>
             <a:ext uri="{C572A759-6A51-4108-AA02-DFA0A04FC94B}">
-              <ma14:wrappingTextBoxFlag xmlns:ma14="http://schemas.microsoft.com/office/mac/drawingml/2011/main" xmlns="" val="1"/>
+              <ma14:wrappingTextBoxFlag xmlns="" xmlns:ma14="http://schemas.microsoft.com/office/mac/drawingml/2011/main" val="1"/>
             </a:ext>
           </a:extLst>
         </p:spPr>
@@ -13580,7 +13580,7 @@
           </a:ln>
           <a:extLst>
             <a:ext uri="{C572A759-6A51-4108-AA02-DFA0A04FC94B}">
-              <ma14:wrappingTextBoxFlag xmlns="" xmlns:ma14="http://schemas.microsoft.com/office/mac/drawingml/2011/main" val="1"/>
+              <ma14:wrappingTextBoxFlag xmlns:ma14="http://schemas.microsoft.com/office/mac/drawingml/2011/main" xmlns="" val="1"/>
             </a:ext>
           </a:extLst>
         </p:spPr>
@@ -13784,7 +13784,7 @@
           </a:ln>
           <a:extLst>
             <a:ext uri="{C572A759-6A51-4108-AA02-DFA0A04FC94B}">
-              <ma14:wrappingTextBoxFlag xmlns="" xmlns:ma14="http://schemas.microsoft.com/office/mac/drawingml/2011/main" val="1"/>
+              <ma14:wrappingTextBoxFlag xmlns:ma14="http://schemas.microsoft.com/office/mac/drawingml/2011/main" xmlns="" val="1"/>
             </a:ext>
           </a:extLst>
         </p:spPr>
@@ -13947,7 +13947,7 @@
           </a:ln>
           <a:extLst>
             <a:ext uri="{C572A759-6A51-4108-AA02-DFA0A04FC94B}">
-              <ma14:wrappingTextBoxFlag xmlns="" xmlns:ma14="http://schemas.microsoft.com/office/mac/drawingml/2011/main" val="1"/>
+              <ma14:wrappingTextBoxFlag xmlns:ma14="http://schemas.microsoft.com/office/mac/drawingml/2011/main" xmlns="" val="1"/>
             </a:ext>
           </a:extLst>
         </p:spPr>
@@ -14308,7 +14308,7 @@
           </a:ln>
           <a:extLst>
             <a:ext uri="{C572A759-6A51-4108-AA02-DFA0A04FC94B}">
-              <ma14:wrappingTextBoxFlag xmlns="" xmlns:ma14="http://schemas.microsoft.com/office/mac/drawingml/2011/main" val="1"/>
+              <ma14:wrappingTextBoxFlag xmlns:ma14="http://schemas.microsoft.com/office/mac/drawingml/2011/main" xmlns="" val="1"/>
             </a:ext>
           </a:extLst>
         </p:spPr>
@@ -14424,7 +14424,7 @@
           </a:ln>
           <a:extLst>
             <a:ext uri="{C572A759-6A51-4108-AA02-DFA0A04FC94B}">
-              <ma14:wrappingTextBoxFlag xmlns="" xmlns:ma14="http://schemas.microsoft.com/office/mac/drawingml/2011/main" val="1"/>
+              <ma14:wrappingTextBoxFlag xmlns:ma14="http://schemas.microsoft.com/office/mac/drawingml/2011/main" xmlns="" val="1"/>
             </a:ext>
           </a:extLst>
         </p:spPr>
@@ -14530,7 +14530,7 @@
           </a:ln>
           <a:extLst>
             <a:ext uri="{C572A759-6A51-4108-AA02-DFA0A04FC94B}">
-              <ma14:wrappingTextBoxFlag xmlns="" xmlns:ma14="http://schemas.microsoft.com/office/mac/drawingml/2011/main" val="1"/>
+              <ma14:wrappingTextBoxFlag xmlns:ma14="http://schemas.microsoft.com/office/mac/drawingml/2011/main" xmlns="" val="1"/>
             </a:ext>
           </a:extLst>
         </p:spPr>
@@ -14636,7 +14636,7 @@
           </a:ln>
           <a:extLst>
             <a:ext uri="{C572A759-6A51-4108-AA02-DFA0A04FC94B}">
-              <ma14:wrappingTextBoxFlag xmlns="" xmlns:ma14="http://schemas.microsoft.com/office/mac/drawingml/2011/main" val="1"/>
+              <ma14:wrappingTextBoxFlag xmlns:ma14="http://schemas.microsoft.com/office/mac/drawingml/2011/main" xmlns="" val="1"/>
             </a:ext>
           </a:extLst>
         </p:spPr>
@@ -14686,7 +14686,7 @@
           </a:ln>
           <a:extLst>
             <a:ext uri="{C572A759-6A51-4108-AA02-DFA0A04FC94B}">
-              <ma14:wrappingTextBoxFlag xmlns="" xmlns:ma14="http://schemas.microsoft.com/office/mac/drawingml/2011/main" val="1"/>
+              <ma14:wrappingTextBoxFlag xmlns:ma14="http://schemas.microsoft.com/office/mac/drawingml/2011/main" xmlns="" val="1"/>
             </a:ext>
           </a:extLst>
         </p:spPr>
@@ -14803,7 +14803,7 @@
           </a:ln>
           <a:extLst>
             <a:ext uri="{C572A759-6A51-4108-AA02-DFA0A04FC94B}">
-              <ma14:wrappingTextBoxFlag xmlns="" xmlns:ma14="http://schemas.microsoft.com/office/mac/drawingml/2011/main" val="1"/>
+              <ma14:wrappingTextBoxFlag xmlns:ma14="http://schemas.microsoft.com/office/mac/drawingml/2011/main" xmlns="" val="1"/>
             </a:ext>
           </a:extLst>
         </p:spPr>
@@ -15036,7 +15036,7 @@
           </a:ln>
           <a:extLst>
             <a:ext uri="{C572A759-6A51-4108-AA02-DFA0A04FC94B}">
-              <ma14:wrappingTextBoxFlag xmlns="" xmlns:ma14="http://schemas.microsoft.com/office/mac/drawingml/2011/main" val="1"/>
+              <ma14:wrappingTextBoxFlag xmlns:ma14="http://schemas.microsoft.com/office/mac/drawingml/2011/main" xmlns="" val="1"/>
             </a:ext>
           </a:extLst>
         </p:spPr>
@@ -15086,7 +15086,7 @@
           </a:ln>
           <a:extLst>
             <a:ext uri="{C572A759-6A51-4108-AA02-DFA0A04FC94B}">
-              <ma14:wrappingTextBoxFlag xmlns="" xmlns:ma14="http://schemas.microsoft.com/office/mac/drawingml/2011/main" val="1"/>
+              <ma14:wrappingTextBoxFlag xmlns:ma14="http://schemas.microsoft.com/office/mac/drawingml/2011/main" xmlns="" val="1"/>
             </a:ext>
           </a:extLst>
         </p:spPr>
@@ -15981,7 +15981,7 @@
           </a:ln>
           <a:extLst>
             <a:ext uri="{C572A759-6A51-4108-AA02-DFA0A04FC94B}">
-              <ma14:wrappingTextBoxFlag xmlns="" xmlns:ma14="http://schemas.microsoft.com/office/mac/drawingml/2011/main" val="1"/>
+              <ma14:wrappingTextBoxFlag xmlns:ma14="http://schemas.microsoft.com/office/mac/drawingml/2011/main" xmlns="" val="1"/>
             </a:ext>
           </a:extLst>
         </p:spPr>
@@ -16165,7 +16165,7 @@
           </a:ln>
           <a:extLst>
             <a:ext uri="{C572A759-6A51-4108-AA02-DFA0A04FC94B}">
-              <ma14:wrappingTextBoxFlag xmlns="" xmlns:ma14="http://schemas.microsoft.com/office/mac/drawingml/2011/main" val="1"/>
+              <ma14:wrappingTextBoxFlag xmlns:ma14="http://schemas.microsoft.com/office/mac/drawingml/2011/main" xmlns="" val="1"/>
             </a:ext>
           </a:extLst>
         </p:spPr>
@@ -16312,7 +16312,7 @@
           </a:ln>
           <a:extLst>
             <a:ext uri="{C572A759-6A51-4108-AA02-DFA0A04FC94B}">
-              <ma14:wrappingTextBoxFlag xmlns="" xmlns:ma14="http://schemas.microsoft.com/office/mac/drawingml/2011/main" val="1"/>
+              <ma14:wrappingTextBoxFlag xmlns:ma14="http://schemas.microsoft.com/office/mac/drawingml/2011/main" xmlns="" val="1"/>
             </a:ext>
           </a:extLst>
         </p:spPr>
@@ -16469,7 +16469,7 @@
           </a:ln>
           <a:extLst>
             <a:ext uri="{C572A759-6A51-4108-AA02-DFA0A04FC94B}">
-              <ma14:wrappingTextBoxFlag xmlns:ma14="http://schemas.microsoft.com/office/mac/drawingml/2011/main" xmlns="" val="1"/>
+              <ma14:wrappingTextBoxFlag xmlns="" xmlns:ma14="http://schemas.microsoft.com/office/mac/drawingml/2011/main" val="1"/>
             </a:ext>
           </a:extLst>
         </p:spPr>
@@ -16621,7 +16621,7 @@
           </a:ln>
           <a:extLst>
             <a:ext uri="{C572A759-6A51-4108-AA02-DFA0A04FC94B}">
-              <ma14:wrappingTextBoxFlag xmlns="" xmlns:ma14="http://schemas.microsoft.com/office/mac/drawingml/2011/main" val="1"/>
+              <ma14:wrappingTextBoxFlag xmlns:ma14="http://schemas.microsoft.com/office/mac/drawingml/2011/main" xmlns="" val="1"/>
             </a:ext>
           </a:extLst>
         </p:spPr>
@@ -17197,7 +17197,7 @@
           </a:ln>
           <a:extLst>
             <a:ext uri="{C572A759-6A51-4108-AA02-DFA0A04FC94B}">
-              <ma14:wrappingTextBoxFlag xmlns:ma14="http://schemas.microsoft.com/office/mac/drawingml/2011/main" xmlns="" val="1"/>
+              <ma14:wrappingTextBoxFlag xmlns="" xmlns:ma14="http://schemas.microsoft.com/office/mac/drawingml/2011/main" val="1"/>
             </a:ext>
           </a:extLst>
         </p:spPr>
@@ -17732,7 +17732,7 @@
           <a:p>
             <a:r>
               <a:rPr lang="en-US" dirty="0"/>
-              <a:t>64</a:t>
+              <a:t>72</a:t>
             </a:r>
             <a:endParaRPr dirty="0"/>
           </a:p>
@@ -17799,7 +17799,7 @@
           </a:ln>
           <a:extLst>
             <a:ext uri="{C572A759-6A51-4108-AA02-DFA0A04FC94B}">
-              <ma14:wrappingTextBoxFlag xmlns="" xmlns:ma14="http://schemas.microsoft.com/office/mac/drawingml/2011/main" val="1"/>
+              <ma14:wrappingTextBoxFlag xmlns:ma14="http://schemas.microsoft.com/office/mac/drawingml/2011/main" xmlns="" val="1"/>
             </a:ext>
           </a:extLst>
         </p:spPr>
@@ -17933,7 +17933,7 @@
           </a:ln>
           <a:extLst>
             <a:ext uri="{C572A759-6A51-4108-AA02-DFA0A04FC94B}">
-              <ma14:wrappingTextBoxFlag xmlns="" xmlns:ma14="http://schemas.microsoft.com/office/mac/drawingml/2011/main" val="1"/>
+              <ma14:wrappingTextBoxFlag xmlns:ma14="http://schemas.microsoft.com/office/mac/drawingml/2011/main" xmlns="" val="1"/>
             </a:ext>
           </a:extLst>
         </p:spPr>
@@ -18266,7 +18266,7 @@
                 <a:effectLst/>
                 <a:hlinkClick r:id="rId3"/>
               </a:rPr>
-              <a:t>https://fhir-open.cerner.com/r4/ec2458f2-1e24-41c8-b71b-0e701af7583d/MedicationRequest?patient=12724070&amp;status=active&amp;-pageContext=T3BlblBsYXRmb3JtRmhpckNvbnRleHQ9dHJ1ZSZwYWdlQ29udGV4dD00ODM4MTE5NzdfNDgzODEyNjgxXzEyNzI0MDcwXzFfMSZjb25jZXB0PWNoYXJ0ZWQ%3D&amp;-pageDirection=NEXT&amp;_format=json</a:t>
+              <a:t>https://fhir-open.cerner.com/r4/ec2458f2-1e24-41c8-b71b-0e701af7583d/MedicationRequest?patient=12724070&amp;status=active&amp;-pageContext=T3BlblBsYXRmb3JtRmhpckNvbnRleHQ9dHJ1ZSZwYWdlQ29udGV4dD04OTAzMzYwMTdfODkwMzM2MDg4XzEyNzI0MDcwXzFfMSZjb25jZXB0PWNoYXJ0ZWQ%3D&amp;-pageDirection=NEXT&amp;_format=json</a:t>
             </a:r>
             <a:endParaRPr dirty="0">
               <a:hlinkClick r:id="rId4"/>
@@ -18364,7 +18364,7 @@
               <a:rPr lang="en-US" u="sng" dirty="0">
                 <a:hlinkClick r:id="rId2"/>
               </a:rPr>
-              <a:t>https://fhir-open.cerner.com/r4/ec2458f2-1e24-41c8-b71b-0e701af7583d/MedicationRequest?patient=12724070&amp;status=active&amp;-pageContext=T3BlblBsYXRmb3JtRmhpckNvbnRleHQ9dHJ1ZSZwYWdlQ29udGV4dD00ODM4MTE5NzdfNDgzODEyNjgxXzEyNzI0MDcwXzFfMSZjb25jZXB0PWNoYXJ0ZWQ%3D&amp;-pageDirection=NEXT&amp;_format=json</a:t>
+              <a:t>https://fhir-open.cerner.com/r4/ec2458f2-1e24-41c8-b71b-0e701af7583d/MedicationRequest?patient=12724070&amp;status=active&amp;-pageContext=T3BlblBsYXRmb3JtRmhpckNvbnRleHQ9dHJ1ZSZwYWdlQ29udGV4dD04OTAzMzYwMTdfODkwMzM2MDg4XzEyNzI0MDcwXzFfMSZjb25jZXB0PWNoYXJ0ZWQ%3D&amp;-pageDirection=NEXT&amp;_format=json</a:t>
             </a:r>
             <a:endParaRPr u="sng" dirty="0">
               <a:hlinkClick r:id="rId3"/>
@@ -18467,7 +18467,7 @@
           </a:ln>
           <a:extLst>
             <a:ext uri="{C572A759-6A51-4108-AA02-DFA0A04FC94B}">
-              <ma14:wrappingTextBoxFlag xmlns="" xmlns:ma14="http://schemas.microsoft.com/office/mac/drawingml/2011/main" val="1"/>
+              <ma14:wrappingTextBoxFlag xmlns:ma14="http://schemas.microsoft.com/office/mac/drawingml/2011/main" xmlns="" val="1"/>
             </a:ext>
           </a:extLst>
         </p:spPr>
@@ -18584,7 +18584,7 @@
           </a:ln>
           <a:extLst>
             <a:ext uri="{C572A759-6A51-4108-AA02-DFA0A04FC94B}">
-              <ma14:wrappingTextBoxFlag xmlns="" xmlns:ma14="http://schemas.microsoft.com/office/mac/drawingml/2011/main" val="1"/>
+              <ma14:wrappingTextBoxFlag xmlns:ma14="http://schemas.microsoft.com/office/mac/drawingml/2011/main" xmlns="" val="1"/>
             </a:ext>
           </a:extLst>
         </p:spPr>
@@ -19044,7 +19044,7 @@
           </a:ln>
           <a:extLst>
             <a:ext uri="{C572A759-6A51-4108-AA02-DFA0A04FC94B}">
-              <ma14:wrappingTextBoxFlag xmlns="" xmlns:ma14="http://schemas.microsoft.com/office/mac/drawingml/2011/main" val="1"/>
+              <ma14:wrappingTextBoxFlag xmlns:ma14="http://schemas.microsoft.com/office/mac/drawingml/2011/main" xmlns="" val="1"/>
             </a:ext>
           </a:extLst>
         </p:spPr>
@@ -19187,7 +19187,7 @@
           </a:ln>
           <a:extLst>
             <a:ext uri="{C572A759-6A51-4108-AA02-DFA0A04FC94B}">
-              <ma14:wrappingTextBoxFlag xmlns="" xmlns:ma14="http://schemas.microsoft.com/office/mac/drawingml/2011/main" val="1"/>
+              <ma14:wrappingTextBoxFlag xmlns:ma14="http://schemas.microsoft.com/office/mac/drawingml/2011/main" xmlns="" val="1"/>
             </a:ext>
           </a:extLst>
         </p:spPr>
@@ -19772,7 +19772,7 @@
           </a:ln>
           <a:extLst>
             <a:ext uri="{C572A759-6A51-4108-AA02-DFA0A04FC94B}">
-              <ma14:wrappingTextBoxFlag xmlns="" xmlns:ma14="http://schemas.microsoft.com/office/mac/drawingml/2011/main" val="1"/>
+              <ma14:wrappingTextBoxFlag xmlns:ma14="http://schemas.microsoft.com/office/mac/drawingml/2011/main" xmlns="" val="1"/>
             </a:ext>
           </a:extLst>
         </p:spPr>
@@ -19824,7 +19824,7 @@
           </a:ln>
           <a:extLst>
             <a:ext uri="{C572A759-6A51-4108-AA02-DFA0A04FC94B}">
-              <ma14:wrappingTextBoxFlag xmlns="" xmlns:ma14="http://schemas.microsoft.com/office/mac/drawingml/2011/main" val="1"/>
+              <ma14:wrappingTextBoxFlag xmlns:ma14="http://schemas.microsoft.com/office/mac/drawingml/2011/main" xmlns="" val="1"/>
             </a:ext>
           </a:extLst>
         </p:spPr>
@@ -19927,7 +19927,7 @@
           </a:ln>
           <a:extLst>
             <a:ext uri="{C572A759-6A51-4108-AA02-DFA0A04FC94B}">
-              <ma14:wrappingTextBoxFlag xmlns="" xmlns:ma14="http://schemas.microsoft.com/office/mac/drawingml/2011/main" val="1"/>
+              <ma14:wrappingTextBoxFlag xmlns:ma14="http://schemas.microsoft.com/office/mac/drawingml/2011/main" xmlns="" val="1"/>
             </a:ext>
           </a:extLst>
         </p:spPr>
@@ -20041,7 +20041,7 @@
           </a:ln>
           <a:extLst>
             <a:ext uri="{C572A759-6A51-4108-AA02-DFA0A04FC94B}">
-              <ma14:wrappingTextBoxFlag xmlns="" xmlns:ma14="http://schemas.microsoft.com/office/mac/drawingml/2011/main" val="1"/>
+              <ma14:wrappingTextBoxFlag xmlns:ma14="http://schemas.microsoft.com/office/mac/drawingml/2011/main" xmlns="" val="1"/>
             </a:ext>
           </a:extLst>
         </p:spPr>
@@ -20228,7 +20228,7 @@
           </a:ln>
           <a:extLst>
             <a:ext uri="{C572A759-6A51-4108-AA02-DFA0A04FC94B}">
-              <ma14:wrappingTextBoxFlag xmlns="" xmlns:ma14="http://schemas.microsoft.com/office/mac/drawingml/2011/main" val="1"/>
+              <ma14:wrappingTextBoxFlag xmlns:ma14="http://schemas.microsoft.com/office/mac/drawingml/2011/main" xmlns="" val="1"/>
             </a:ext>
           </a:extLst>
         </p:spPr>
@@ -20898,7 +20898,7 @@
           </a:ln>
           <a:extLst>
             <a:ext uri="{C572A759-6A51-4108-AA02-DFA0A04FC94B}">
-              <ma14:wrappingTextBoxFlag xmlns:ma14="http://schemas.microsoft.com/office/mac/drawingml/2011/main" xmlns="" val="1"/>
+              <ma14:wrappingTextBoxFlag xmlns="" xmlns:ma14="http://schemas.microsoft.com/office/mac/drawingml/2011/main" val="1"/>
             </a:ext>
           </a:extLst>
         </p:spPr>
@@ -21265,7 +21265,7 @@
           </a:ln>
           <a:extLst>
             <a:ext uri="{C572A759-6A51-4108-AA02-DFA0A04FC94B}">
-              <ma14:wrappingTextBoxFlag xmlns:ma14="http://schemas.microsoft.com/office/mac/drawingml/2011/main" xmlns="" val="1"/>
+              <ma14:wrappingTextBoxFlag xmlns="" xmlns:ma14="http://schemas.microsoft.com/office/mac/drawingml/2011/main" val="1"/>
             </a:ext>
           </a:extLst>
         </p:spPr>
@@ -21432,7 +21432,7 @@
           </a:ln>
           <a:extLst>
             <a:ext uri="{C572A759-6A51-4108-AA02-DFA0A04FC94B}">
-              <ma14:wrappingTextBoxFlag xmlns:ma14="http://schemas.microsoft.com/office/mac/drawingml/2011/main" xmlns="" val="1"/>
+              <ma14:wrappingTextBoxFlag xmlns="" xmlns:ma14="http://schemas.microsoft.com/office/mac/drawingml/2011/main" val="1"/>
             </a:ext>
           </a:extLst>
         </p:spPr>
@@ -21499,7 +21499,7 @@
           </a:ln>
           <a:extLst>
             <a:ext uri="{C572A759-6A51-4108-AA02-DFA0A04FC94B}">
-              <ma14:wrappingTextBoxFlag xmlns="" xmlns:ma14="http://schemas.microsoft.com/office/mac/drawingml/2011/main" val="1"/>
+              <ma14:wrappingTextBoxFlag xmlns:ma14="http://schemas.microsoft.com/office/mac/drawingml/2011/main" xmlns="" val="1"/>
             </a:ext>
           </a:extLst>
         </p:spPr>
@@ -21690,7 +21690,7 @@
           </a:ln>
           <a:extLst>
             <a:ext uri="{C572A759-6A51-4108-AA02-DFA0A04FC94B}">
-              <ma14:wrappingTextBoxFlag xmlns="" xmlns:ma14="http://schemas.microsoft.com/office/mac/drawingml/2011/main" val="1"/>
+              <ma14:wrappingTextBoxFlag xmlns:ma14="http://schemas.microsoft.com/office/mac/drawingml/2011/main" xmlns="" val="1"/>
             </a:ext>
           </a:extLst>
         </p:spPr>
@@ -21831,7 +21831,7 @@
           </a:ln>
           <a:extLst>
             <a:ext uri="{C572A759-6A51-4108-AA02-DFA0A04FC94B}">
-              <ma14:wrappingTextBoxFlag xmlns="" xmlns:ma14="http://schemas.microsoft.com/office/mac/drawingml/2011/main" val="1"/>
+              <ma14:wrappingTextBoxFlag xmlns:ma14="http://schemas.microsoft.com/office/mac/drawingml/2011/main" xmlns="" val="1"/>
             </a:ext>
           </a:extLst>
         </p:spPr>
@@ -22565,7 +22565,7 @@
           </a:ln>
           <a:extLst>
             <a:ext uri="{C572A759-6A51-4108-AA02-DFA0A04FC94B}">
-              <ma14:wrappingTextBoxFlag xmlns="" xmlns:ma14="http://schemas.microsoft.com/office/mac/drawingml/2011/main" val="1"/>
+              <ma14:wrappingTextBoxFlag xmlns:ma14="http://schemas.microsoft.com/office/mac/drawingml/2011/main" xmlns="" val="1"/>
             </a:ext>
           </a:extLst>
         </p:spPr>
@@ -22938,7 +22938,7 @@
           <a:p>
             <a:r>
               <a:rPr lang="en-US" dirty="0"/>
-              <a:t>Hard to tell (Unknown/75)</a:t>
+              <a:t>109/59 (normal or slightly low diastolic)</a:t>
             </a:r>
           </a:p>
           <a:p>

</xml_diff>